<commit_message>
docs(deck): title said seven builds, the table lists eight
Adding the Linux CI row to slide 6 made the count wrong in three places: the
slide title, the cover, and the memory card on the Numbers slide. Corrected to
eight, which is what the table actually shows.

Small, but this project's whole pitch is that its claims are accurate, so a
miscount on the results slide is worse here than it would be elsewhere.

Co-Authored-By: Claude Opus 5 (1M context) <noreply@anthropic.com>
</commit_message>
<xml_diff>
--- a/documentation/muinference-deck.pptx
+++ b/documentation/muinference-deck.pptx
@@ -3330,7 +3330,7 @@
                 </a:solidFill>
                 <a:latin typeface="Helvetica Neue"/>
               </a:rPr>
-              <a:t>Same output on seven different systems, bit for bit.</a:t>
+              <a:t>Same output on eight different builds, bit for bit.</a:t>
             </a:r>
           </a:p>
           <a:p>
@@ -3646,7 +3646,7 @@
                 </a:solidFill>
                 <a:latin typeface="Helvetica Neue"/>
               </a:rPr>
-              <a:t>·  Same output on seven systems</a:t>
+              <a:t>·  Same output on eight builds</a:t>
             </a:r>
           </a:p>
           <a:p>
@@ -15847,7 +15847,7 @@
                 </a:solidFill>
                 <a:latin typeface="Helvetica Neue"/>
               </a:rPr>
-              <a:t>Result: seven systems, one hash</a:t>
+              <a:t>Result: eight builds, one hash</a:t>
             </a:r>
           </a:p>
         </p:txBody>
@@ -19083,7 +19083,7 @@
                 </a:solidFill>
                 <a:latin typeface="Helvetica Neue"/>
               </a:rPr>
-              <a:t>Same on all seven systems.
+              <a:t>Same on all eight builds.
 Fixed at build time.</a:t>
             </a:r>
           </a:p>

</xml_diff>